<commit_message>
Dogfood dot architecture, editor screenshot, and pygraphviz self-heal
The dogfood samples + demo deck now use the full dot-laid-out architecture. Launcher self-heals pygraphviz (like resvg) so the dot layout works on a fresh install. READMEs document the in-app visual editor (screenshot) and correct the old 'diagrams are two separate systems' note.
</commit_message>
<xml_diff>
--- a/examples/dogfood/output/deck.pptx
+++ b/examples/dogfood/output/deck.pptx
@@ -6168,7 +6168,7 @@
                 </a:solidFill>
                 <a:latin typeface="IBM Plex Sans"/>
               </a:rPr>
-              <a:t>Data Flow: From Raw Sources to Rendered Output</a:t>
+              <a:t>docloom architecture, end to end</a:t>
             </a:r>
           </a:p>
         </p:txBody>
@@ -6219,7 +6219,7 @@
       </p:sp>
       <p:pic>
         <p:nvPicPr>
-          <p:cNvPr id="4" name="docloom:diagram:anon:2525cff29983" descr="docloom architecture: sources to finished documents"/>
+          <p:cNvPr id="4" name="docloom:diagram:anon:9bd9a0f4086a" descr="docloom architecture (full)"/>
           <p:cNvPicPr>
             <a:picLocks noChangeAspect="1"/>
           </p:cNvPicPr>
@@ -6233,8 +6233,8 @@
         </p:blipFill>
         <p:spPr>
           <a:xfrm>
-            <a:off x="548640" y="2190754"/>
-            <a:ext cx="11094415" cy="1088639"/>
+            <a:off x="548640" y="1298448"/>
+            <a:ext cx="11094415" cy="3536344"/>
           </a:xfrm>
           <a:prstGeom prst="rect">
             <a:avLst/>
@@ -6249,7 +6249,7 @@
         </p:nvSpPr>
         <p:spPr>
           <a:xfrm>
-            <a:off x="548640" y="3315969"/>
+            <a:off x="548640" y="4871368"/>
             <a:ext cx="11094415" cy="201168"/>
           </a:xfrm>
           <a:prstGeom prst="rect">
@@ -6271,7 +6271,7 @@
                 </a:solidFill>
                 <a:latin typeface="IBM Plex Sans"/>
               </a:rPr>
-              <a:t>The model emits validated structure; deterministic renderers produce every format.</a:t>
+              <a:t>The full studio + engine architecture: auth, retrieval, jobs, generation, versioned artifacts, and deterministic rendering.</a:t>
             </a:r>
           </a:p>
         </p:txBody>
@@ -6284,7 +6284,7 @@
         </p:nvSpPr>
         <p:spPr>
           <a:xfrm>
-            <a:off x="548640" y="4120641"/>
+            <a:off x="548640" y="5218840"/>
             <a:ext cx="11094415" cy="922020"/>
           </a:xfrm>
           <a:prstGeom prst="rect">

</xml_diff>